<commit_message>
feat: add evidence and self-rating reporting
</commit_message>
<xml_diff>
--- a/.agents/skills/codex-ai-usage-report/assets/rd-codex-ai-usage-report-template.pptx
+++ b/.agents/skills/codex-ai-usage-report/assets/rd-codex-ai-usage-report-template.pptx
@@ -2,14 +2,14 @@
 <file path=ppt/presentation.xml><?xml version="1.0" encoding="utf-8"?>
 <p:presentation xmlns:p="http://schemas.openxmlformats.org/presentationml/2006/main">
   <p:sldMasterIdLst>
-    <p:sldMasterId xmlns:r="http://schemas.openxmlformats.org/officeDocument/2006/relationships" id="2147483648" r:id="Re6376f81f8dc470b"/>
+    <p:sldMasterId xmlns:r="http://schemas.openxmlformats.org/officeDocument/2006/relationships" id="2147483648" r:id="Rc57b410ff59b474f"/>
   </p:sldMasterIdLst>
   <p:notesMasterIdLst>
-    <p:notesMasterId xmlns:r="http://schemas.openxmlformats.org/officeDocument/2006/relationships" r:id="R66957bcdf74c4a3e"/>
+    <p:notesMasterId xmlns:r="http://schemas.openxmlformats.org/officeDocument/2006/relationships" r:id="R7a247904628c47cc"/>
   </p:notesMasterIdLst>
   <p:sldIdLst>
-    <p:sldId xmlns:r="http://schemas.openxmlformats.org/officeDocument/2006/relationships" id="256" r:id="R82fd2456c56a4bfb"/>
-    <p:sldId xmlns:r="http://schemas.openxmlformats.org/officeDocument/2006/relationships" id="257" r:id="R54d65c40d4564465"/>
+    <p:sldId xmlns:r="http://schemas.openxmlformats.org/officeDocument/2006/relationships" id="256" r:id="Rc736e886ad854467"/>
+    <p:sldId xmlns:r="http://schemas.openxmlformats.org/officeDocument/2006/relationships" id="257" r:id="R4504335d75a64586"/>
   </p:sldIdLst>
   <p:sldSz cx="12192000" cy="6858000"/>
   <p:notesSz cx="6858000" cy="9144000"/>
@@ -443,12 +443,12 @@
           <a:lstStyle xmlns:a="http://schemas.openxmlformats.org/drawingml/2006/main"/>
           <a:p xmlns:a="http://schemas.openxmlformats.org/drawingml/2006/main">
             <a:r>
-              <a:t>模板欄位由 $codex-ai-usage-report 自動填入。使用者只需提供英文姓名與中文姓名。</a:t>
-            </a:r>
-          </a:p>
-          <a:p xmlns:a="http://schemas.openxmlformats.org/drawingml/2006/main">
-            <a:r>
-              <a:t>統計期間由使用者提供起日與迄日，含首尾日（Asia/Taipei）；部門：研發部。</a:t>
+              <a:t>模板欄位由 $codex-ai-usage-report 自動填入。先收集英文姓名、中文姓名、統計起日與統計迄日；完成紀錄分析後再收集五項同仁自評。</a:t>
+            </a:r>
+          </a:p>
+          <a:p xmlns:a="http://schemas.openxmlformats.org/drawingml/2006/main">
+            <a:r>
+              <a:t>統計期間含首尾日（Asia/Taipei）；部門：研發部。</a:t>
             </a:r>
           </a:p>
           <a:p xmlns:a="http://schemas.openxmlformats.org/drawingml/2006/main">
@@ -473,7 +473,7 @@
           </a:p>
           <a:p xmlns:a="http://schemas.openxmlformats.org/drawingml/2006/main">
             <a:r>
-              <a:t>- Template standard: rd-codex-ai-usage-report-template v1</a:t>
+              <a:t>- Template standard: rd-codex-ai-usage-report-template v2</a:t>
             </a:r>
           </a:p>
           <a:p xmlns:a="http://schemas.openxmlformats.org/drawingml/2006/main">
@@ -548,22 +548,22 @@
           <a:lstStyle xmlns:a="http://schemas.openxmlformats.org/drawingml/2006/main"/>
           <a:p xmlns:a="http://schemas.openxmlformats.org/drawingml/2006/main">
             <a:r>
-              <a:t>本頁用於記錄 AI 是否協助實際工作，可作為個人績效與考核的參考之一；不作單一判定或員工排名。</a:t>
-            </a:r>
-          </a:p>
-          <a:p xmlns:a="http://schemas.openxmlformats.org/drawingml/2006/main">
-            <a:r>
-              <a:t>AI Value 使用四個助益面向：任務推進、品質與查核、可複用成果、風險辨識。</a:t>
-            </a:r>
-          </a:p>
-          <a:p xmlns:a="http://schemas.openxmlformats.org/drawingml/2006/main">
-            <a:r>
-              <a:t>有足夠證據時顯示「已觀察」並附短證據；紀錄較少時顯示「初步觀察」或「資料累積中」，不顯示低分。</a:t>
-            </a:r>
-          </a:p>
-          <a:p xmlns:a="http://schemas.openxmlformats.org/drawingml/2006/main">
-            <a:r>
-              <a:t>Skill 覆蓋率為偵測到 SKILL.md 使用的工作紀錄數／工作紀錄總數；同一 Skill 在同一工作最多計 1 次。</a:t>
+              <a:t>本頁保留代表工程應用、AI 綜合應用觀察、Skill 覆蓋率與 AI Value。</a:t>
+            </a:r>
+          </a:p>
+          <a:p xmlns:a="http://schemas.openxmlformats.org/drawingml/2006/main">
+            <a:r>
+              <a:t>AI 綜合應用觀察必須先依可讀取的本機 Codex session 形成，再收集同仁自評；不得由自評分數改寫。</a:t>
+            </a:r>
+          </a:p>
+          <a:p xmlns:a="http://schemas.openxmlformats.org/drawingml/2006/main">
+            <a:r>
+              <a:t>觀察包含使用投入與持續性、任務廣度、任務深度與複雜度、成果與實務價值、品質查核與風險意識、可複用性與成熟度六面向。</a:t>
+            </a:r>
+          </a:p>
+          <a:p xmlns:a="http://schemas.openxmlformats.org/drawingml/2006/main">
+            <a:r>
+              <a:t>不作排名，不用 Token、活躍互動或單一分數直接判定績效，也不虛構 ROI、節省時數或效率百分比。</a:t>
             </a:r>
             <a:endParaRPr/>
           </a:p>
@@ -579,7 +579,7 @@
           </a:p>
           <a:p xmlns:a="http://schemas.openxmlformats.org/drawingml/2006/main">
             <a:r>
-              <a:t>- Template standard: rd-codex-ai-usage-report-template v1</a:t>
+              <a:t>- Template standard: rd-codex-ai-usage-report-template v2</a:t>
             </a:r>
           </a:p>
           <a:p xmlns:a="http://schemas.openxmlformats.org/drawingml/2006/main">
@@ -652,7 +652,7 @@
   </p:cSld>
   <p:clrMap bg1="lt1" tx1="dk1" bg2="lt2" tx2="dk2" accent1="accent1" accent2="accent2" accent3="accent3" accent4="accent4" accent5="accent5" accent6="accent6" hlink="hlink" folHlink="folHlink"/>
   <p:sldLayoutIdLst>
-    <p:sldLayoutId xmlns:r="http://schemas.openxmlformats.org/officeDocument/2006/relationships" id="2147483649" r:id="Rb648a8d0bec74910"/>
+    <p:sldLayoutId xmlns:r="http://schemas.openxmlformats.org/officeDocument/2006/relationships" id="2147483649" r:id="R9627921cc1fb4924"/>
   </p:sldLayoutIdLst>
   <p:txStyles>
     <p:titleStyle>
@@ -1687,7 +1687,7 @@
         </p:spPr>
         <p:txBody>
           <a:bodyPr xmlns:a="http://schemas.openxmlformats.org/drawingml/2006/main" anchor="t">
-            <a:normAutofit fontScale="86389" lnSpcReduction="10000"/>
+            <a:normAutofit fontScale="78889" lnSpcReduction="10000"/>
           </a:bodyPr>
           <a:lstStyle xmlns:a="http://schemas.openxmlformats.org/drawingml/2006/main"/>
           <a:p xmlns:a="http://schemas.openxmlformats.org/drawingml/2006/main">
@@ -1711,7 +1711,7 @@
                 <a:ea typeface="Arial"/>
                 <a:cs typeface="Arial"/>
               </a:rPr>
-              <a:t>Top 專案｜AI 工作紀錄分布</a:t>
+              <a:t>工作分類｜AI 工作紀錄分布</a:t>
             </a:r>
           </a:p>
         </p:txBody>
@@ -1728,7 +1728,7 @@
         </p:xfrm>
         <a:graphic xmlns:a="http://schemas.openxmlformats.org/drawingml/2006/main">
           <a:graphicData uri="http://schemas.openxmlformats.org/drawingml/2006/chart">
-            <c:chart xmlns:r="http://schemas.openxmlformats.org/officeDocument/2006/relationships" xmlns:c="http://schemas.openxmlformats.org/drawingml/2006/chart" r:id="R2edbc4cd884641a6"/>
+            <c:chart xmlns:r="http://schemas.openxmlformats.org/officeDocument/2006/relationships" xmlns:c="http://schemas.openxmlformats.org/drawingml/2006/chart" r:id="R62cb11b58f514368"/>
           </a:graphicData>
         </a:graphic>
       </p:graphicFrame>
@@ -3347,7 +3347,7 @@
                 <a:ea typeface="Arial"/>
                 <a:cs typeface="Arial"/>
               </a:rPr>
-              <a:t>AI 已介入設計審查、工程分析與技術交付</a:t>
+              <a:t>Codex 工作紀錄｜代表應用與 AI Value</a:t>
             </a:r>
           </a:p>
         </p:txBody>
@@ -4168,7 +4168,7 @@
                 <a:ea typeface="Arial"/>
                 <a:cs typeface="Arial"/>
               </a:rPr>
-              <a:t>其餘工作｜0 個群組</a:t>
+              <a:t>AI 綜合應用觀察</a:t>
             </a:r>
           </a:p>
         </p:txBody>
@@ -4209,7 +4209,7 @@
           <a:p xmlns:a="http://schemas.openxmlformats.org/drawingml/2006/main">
             <a:pPr algn="l">
               <a:buNone/>
-              <a:defRPr sz="1500" b="0">
+              <a:defRPr sz="1050" b="0">
                 <a:solidFill>
                   <a:srgbClr val="667085"/>
                 </a:solidFill>
@@ -4219,7 +4219,7 @@
               </a:defRPr>
             </a:pPr>
             <a:r>
-              <a:rPr sz="1500" b="0">
+              <a:rPr sz="1050" b="0">
                 <a:solidFill>
                   <a:srgbClr val="667085"/>
                 </a:solidFill>
@@ -4227,79 +4227,7 @@
                 <a:ea typeface="Arial"/>
                 <a:cs typeface="Arial"/>
               </a:rPr>
-              <a:t>• 資料累積中</a:t>
-            </a:r>
-          </a:p>
-          <a:p xmlns:a="http://schemas.openxmlformats.org/drawingml/2006/main">
-            <a:pPr algn="l">
-              <a:buNone/>
-              <a:defRPr sz="1500" b="0">
-                <a:solidFill>
-                  <a:srgbClr val="667085"/>
-                </a:solidFill>
-                <a:latin typeface="Arial"/>
-                <a:ea typeface="Arial"/>
-                <a:cs typeface="Arial"/>
-              </a:defRPr>
-            </a:pPr>
-            <a:r>
-              <a:rPr sz="1500" b="0">
-                <a:solidFill>
-                  <a:srgbClr val="667085"/>
-                </a:solidFill>
-                <a:latin typeface="Arial"/>
-                <a:ea typeface="Arial"/>
-                <a:cs typeface="Arial"/>
-              </a:rPr>
-              <a:t>• —</a:t>
-            </a:r>
-          </a:p>
-          <a:p xmlns:a="http://schemas.openxmlformats.org/drawingml/2006/main">
-            <a:pPr algn="l">
-              <a:buNone/>
-              <a:defRPr sz="1500" b="0">
-                <a:solidFill>
-                  <a:srgbClr val="667085"/>
-                </a:solidFill>
-                <a:latin typeface="Arial"/>
-                <a:ea typeface="Arial"/>
-                <a:cs typeface="Arial"/>
-              </a:defRPr>
-            </a:pPr>
-            <a:r>
-              <a:rPr sz="1500" b="0">
-                <a:solidFill>
-                  <a:srgbClr val="667085"/>
-                </a:solidFill>
-                <a:latin typeface="Arial"/>
-                <a:ea typeface="Arial"/>
-                <a:cs typeface="Arial"/>
-              </a:rPr>
-              <a:t>• —</a:t>
-            </a:r>
-          </a:p>
-          <a:p xmlns:a="http://schemas.openxmlformats.org/drawingml/2006/main">
-            <a:pPr algn="l">
-              <a:buNone/>
-              <a:defRPr sz="1500" b="0">
-                <a:solidFill>
-                  <a:srgbClr val="667085"/>
-                </a:solidFill>
-                <a:latin typeface="Arial"/>
-                <a:ea typeface="Arial"/>
-                <a:cs typeface="Arial"/>
-              </a:defRPr>
-            </a:pPr>
-            <a:r>
-              <a:rPr sz="1500" b="0">
-                <a:solidFill>
-                  <a:srgbClr val="667085"/>
-                </a:solidFill>
-                <a:latin typeface="Arial"/>
-                <a:ea typeface="Arial"/>
-                <a:cs typeface="Arial"/>
-              </a:rPr>
-              <a:t>• —</a:t>
+              <a:t>本期依本機 Codex 工作紀錄整理的個人化應用觀察，將依實際任務、成果與查核證據產生。</a:t>
             </a:r>
           </a:p>
         </p:txBody>
@@ -4726,138 +4654,7 @@
                 <a:ea typeface="Arial"/>
                 <a:cs typeface="Arial"/>
               </a:rPr>
-              <a:t>AI Value｜助益觀察</a:t>
-            </a:r>
-          </a:p>
-        </p:txBody>
-      </p:sp>
-      <p:sp>
-        <p:nvSpPr>
-          <p:cNvPr id="24" name="slide-2-value-body-3">
-            <a:extLst xmlns:a="http://schemas.openxmlformats.org/drawingml/2006/main">
-              <a:ext uri="{FF2B5EF4-FFF2-40B4-BE49-F238E27FC236}">
-                <a16:creationId xmlns:a16="http://schemas.microsoft.com/office/drawing/2014/main" id="{79A360AB-9620-4575-8955-02C0CC2984F1}"/>
-              </a:ext>
-            </a:extLst>
-          </p:cNvPr>
-          <p:cNvSpPr>
-            <a:spLocks xmlns:a="http://schemas.openxmlformats.org/drawingml/2006/main" noGrp="1"/>
-          </p:cNvSpPr>
-          <p:nvPr/>
-        </p:nvSpPr>
-        <p:spPr>
-          <a:xfrm xmlns:a="http://schemas.openxmlformats.org/drawingml/2006/main">
-            <a:off x="8420100" y="4267200"/>
-            <a:ext cx="3048000" cy="1333500"/>
-          </a:xfrm>
-          <a:prstGeom xmlns:a="http://schemas.openxmlformats.org/drawingml/2006/main" prst="rect">
-            <a:avLst/>
-          </a:prstGeom>
-          <a:noFill xmlns:a="http://schemas.openxmlformats.org/drawingml/2006/main"/>
-          <a:ln xmlns:a="http://schemas.openxmlformats.org/drawingml/2006/main" w="0">
-            <a:noFill/>
-            <a:prstDash val="solid"/>
-          </a:ln>
-        </p:spPr>
-        <p:txBody>
-          <a:bodyPr xmlns:a="http://schemas.openxmlformats.org/drawingml/2006/main" anchor="t">
-            <a:normAutofit fontScale="100000"/>
-          </a:bodyPr>
-          <a:lstStyle xmlns:a="http://schemas.openxmlformats.org/drawingml/2006/main"/>
-          <a:p xmlns:a="http://schemas.openxmlformats.org/drawingml/2006/main">
-            <a:pPr algn="l">
-              <a:buNone/>
-              <a:defRPr sz="1500" b="0">
-                <a:solidFill>
-                  <a:srgbClr val="667085"/>
-                </a:solidFill>
-                <a:latin typeface="Arial"/>
-                <a:ea typeface="Arial"/>
-                <a:cs typeface="Arial"/>
-              </a:defRPr>
-            </a:pPr>
-            <a:r>
-              <a:rPr sz="1500" b="0">
-                <a:solidFill>
-                  <a:srgbClr val="667085"/>
-                </a:solidFill>
-                <a:latin typeface="Arial"/>
-                <a:ea typeface="Arial"/>
-                <a:cs typeface="Arial"/>
-              </a:rPr>
-              <a:t>• 任務推進｜資料累積中</a:t>
-            </a:r>
-          </a:p>
-          <a:p xmlns:a="http://schemas.openxmlformats.org/drawingml/2006/main">
-            <a:pPr algn="l">
-              <a:buNone/>
-              <a:defRPr sz="1500" b="0">
-                <a:solidFill>
-                  <a:srgbClr val="667085"/>
-                </a:solidFill>
-                <a:latin typeface="Arial"/>
-                <a:ea typeface="Arial"/>
-                <a:cs typeface="Arial"/>
-              </a:defRPr>
-            </a:pPr>
-            <a:r>
-              <a:rPr sz="1500" b="0">
-                <a:solidFill>
-                  <a:srgbClr val="667085"/>
-                </a:solidFill>
-                <a:latin typeface="Arial"/>
-                <a:ea typeface="Arial"/>
-                <a:cs typeface="Arial"/>
-              </a:rPr>
-              <a:t>• 品質與查核｜資料累積中</a:t>
-            </a:r>
-          </a:p>
-          <a:p xmlns:a="http://schemas.openxmlformats.org/drawingml/2006/main">
-            <a:pPr algn="l">
-              <a:buNone/>
-              <a:defRPr sz="1500" b="0">
-                <a:solidFill>
-                  <a:srgbClr val="667085"/>
-                </a:solidFill>
-                <a:latin typeface="Arial"/>
-                <a:ea typeface="Arial"/>
-                <a:cs typeface="Arial"/>
-              </a:defRPr>
-            </a:pPr>
-            <a:r>
-              <a:rPr sz="1500" b="0">
-                <a:solidFill>
-                  <a:srgbClr val="667085"/>
-                </a:solidFill>
-                <a:latin typeface="Arial"/>
-                <a:ea typeface="Arial"/>
-                <a:cs typeface="Arial"/>
-              </a:rPr>
-              <a:t>• 可複用成果｜資料累積中</a:t>
-            </a:r>
-          </a:p>
-          <a:p xmlns:a="http://schemas.openxmlformats.org/drawingml/2006/main">
-            <a:pPr algn="l">
-              <a:buNone/>
-              <a:defRPr sz="1500" b="0">
-                <a:solidFill>
-                  <a:srgbClr val="667085"/>
-                </a:solidFill>
-                <a:latin typeface="Arial"/>
-                <a:ea typeface="Arial"/>
-                <a:cs typeface="Arial"/>
-              </a:defRPr>
-            </a:pPr>
-            <a:r>
-              <a:rPr sz="1500" b="0">
-                <a:solidFill>
-                  <a:srgbClr val="667085"/>
-                </a:solidFill>
-                <a:latin typeface="Arial"/>
-                <a:ea typeface="Arial"/>
-                <a:cs typeface="Arial"/>
-              </a:rPr>
-              <a:t>• 風險辨識｜資料累積中</a:t>
+              <a:t>AI 的證據與自評</a:t>
             </a:r>
           </a:p>
         </p:txBody>
@@ -4916,7 +4713,7 @@
                 <a:ea typeface="Arial"/>
                 <a:cs typeface="Arial"/>
               </a:rPr>
-              <a:t>AI Value 記錄 AI 的實際工作助益，供績效考核參考之一；不作單一判定或排名。</a:t>
+              <a:t>AI 建議｜依本期可回溯的工作證據產生個人化下一步建議。</a:t>
             </a:r>
           </a:p>
         </p:txBody>
@@ -4980,6 +4777,491 @@
           </a:p>
         </p:txBody>
       </p:sp>
+      <p:graphicFrame>
+        <p:nvGraphicFramePr>
+          <p:cNvPr id="54" name="slide-2-value-table-3"/>
+          <p:cNvGraphicFramePr/>
+          <p:nvPr/>
+        </p:nvGraphicFramePr>
+        <p:xfrm>
+          <a:off xmlns:a="http://schemas.openxmlformats.org/drawingml/2006/main" x="8420100" y="4267200"/>
+          <a:ext xmlns:a="http://schemas.openxmlformats.org/drawingml/2006/main" cx="3048000" cy="1333500"/>
+        </p:xfrm>
+        <a:graphic xmlns:a="http://schemas.openxmlformats.org/drawingml/2006/main">
+          <a:graphicData uri="http://schemas.openxmlformats.org/drawingml/2006/table">
+            <a:tbl>
+              <a:tblPr firstRow="0" firstCol="0" lastRow="0" lastCol="0" bandRow="0" bandCol="0"/>
+              <a:tblGrid>
+                <a:gridCol w="1428750"/>
+                <a:gridCol w="809625"/>
+                <a:gridCol w="809625"/>
+              </a:tblGrid>
+              <a:tr h="209550">
+                <a:tc>
+                  <a:txBody>
+                    <a:bodyPr/>
+                    <a:lstStyle/>
+                    <a:p>
+                      <a:pPr algn="ctr"/>
+                      <a:r>
+                        <a:rPr sz="788" b="1">
+                          <a:solidFill>
+                            <a:srgbClr val="155DCC"/>
+                          </a:solidFill>
+                          <a:latin typeface="Arial"/>
+                          <a:ea typeface="Arial"/>
+                          <a:cs typeface="Arial"/>
+                        </a:rPr>
+                        <a:t>面向</a:t>
+                      </a:r>
+                    </a:p>
+                  </a:txBody>
+                  <a:tcPr marL="38100" marR="38100" marT="9525" marB="9525" anchor="ctr">
+                    <a:solidFill>
+                      <a:srgbClr val="EAF2FF"/>
+                    </a:solidFill>
+                  </a:tcPr>
+                </a:tc>
+                <a:tc>
+                  <a:txBody>
+                    <a:bodyPr/>
+                    <a:lstStyle/>
+                    <a:p>
+                      <a:pPr algn="ctr"/>
+                      <a:r>
+                        <a:rPr sz="788" b="1">
+                          <a:solidFill>
+                            <a:srgbClr val="155DCC"/>
+                          </a:solidFill>
+                          <a:latin typeface="Arial"/>
+                          <a:ea typeface="Arial"/>
+                          <a:cs typeface="Arial"/>
+                        </a:rPr>
+                        <a:t>AI 證據</a:t>
+                      </a:r>
+                    </a:p>
+                  </a:txBody>
+                  <a:tcPr marL="38100" marR="38100" marT="9525" marB="9525" anchor="ctr">
+                    <a:solidFill>
+                      <a:srgbClr val="EAF2FF"/>
+                    </a:solidFill>
+                  </a:tcPr>
+                </a:tc>
+                <a:tc>
+                  <a:txBody>
+                    <a:bodyPr/>
+                    <a:lstStyle/>
+                    <a:p>
+                      <a:pPr algn="ctr"/>
+                      <a:r>
+                        <a:rPr sz="788" b="1">
+                          <a:solidFill>
+                            <a:srgbClr val="155DCC"/>
+                          </a:solidFill>
+                          <a:latin typeface="Arial"/>
+                          <a:ea typeface="Arial"/>
+                          <a:cs typeface="Arial"/>
+                        </a:rPr>
+                        <a:t>同仁自評</a:t>
+                      </a:r>
+                    </a:p>
+                  </a:txBody>
+                  <a:tcPr marL="38100" marR="38100" marT="9525" marB="9525" anchor="ctr">
+                    <a:solidFill>
+                      <a:srgbClr val="EAF2FF"/>
+                    </a:solidFill>
+                  </a:tcPr>
+                </a:tc>
+              </a:tr>
+              <a:tr h="224790">
+                <a:tc>
+                  <a:txBody>
+                    <a:bodyPr/>
+                    <a:lstStyle/>
+                    <a:p>
+                      <a:pPr algn="l"/>
+                      <a:r>
+                        <a:rPr sz="825">
+                          <a:solidFill>
+                            <a:srgbClr val="667085"/>
+                          </a:solidFill>
+                          <a:latin typeface="Arial"/>
+                          <a:ea typeface="Arial"/>
+                          <a:cs typeface="Arial"/>
+                        </a:rPr>
+                        <a:t>任務推進</a:t>
+                      </a:r>
+                    </a:p>
+                  </a:txBody>
+                  <a:tcPr marL="38100" marR="38100" marT="9525" marB="9525" anchor="ctr">
+                    <a:solidFill>
+                      <a:srgbClr val="F8FAFC"/>
+                    </a:solidFill>
+                  </a:tcPr>
+                </a:tc>
+                <a:tc>
+                  <a:txBody>
+                    <a:bodyPr/>
+                    <a:lstStyle/>
+                    <a:p>
+                      <a:pPr algn="ctr"/>
+                      <a:r>
+                        <a:rPr sz="900" b="1">
+                          <a:solidFill>
+                            <a:srgbClr val="155DCC"/>
+                          </a:solidFill>
+                          <a:latin typeface="Arial"/>
+                          <a:ea typeface="Arial"/>
+                          <a:cs typeface="Arial"/>
+                        </a:rPr>
+                        <a:t>N/A</a:t>
+                      </a:r>
+                    </a:p>
+                  </a:txBody>
+                  <a:tcPr marL="38100" marR="38100" marT="9525" marB="9525" anchor="ctr">
+                    <a:solidFill>
+                      <a:srgbClr val="F8FAFC"/>
+                    </a:solidFill>
+                  </a:tcPr>
+                </a:tc>
+                <a:tc>
+                  <a:txBody>
+                    <a:bodyPr/>
+                    <a:lstStyle/>
+                    <a:p>
+                      <a:pPr algn="ctr"/>
+                      <a:r>
+                        <a:rPr sz="900" b="1">
+                          <a:solidFill>
+                            <a:srgbClr val="155DCC"/>
+                          </a:solidFill>
+                          <a:latin typeface="Arial"/>
+                          <a:ea typeface="Arial"/>
+                          <a:cs typeface="Arial"/>
+                        </a:rPr>
+                        <a:t>N/A</a:t>
+                      </a:r>
+                    </a:p>
+                  </a:txBody>
+                  <a:tcPr marL="38100" marR="38100" marT="9525" marB="9525" anchor="ctr">
+                    <a:solidFill>
+                      <a:srgbClr val="F8FAFC"/>
+                    </a:solidFill>
+                  </a:tcPr>
+                </a:tc>
+              </a:tr>
+              <a:tr h="224790">
+                <a:tc>
+                  <a:txBody>
+                    <a:bodyPr/>
+                    <a:lstStyle/>
+                    <a:p>
+                      <a:pPr algn="l"/>
+                      <a:r>
+                        <a:rPr sz="825">
+                          <a:solidFill>
+                            <a:srgbClr val="667085"/>
+                          </a:solidFill>
+                          <a:latin typeface="Arial"/>
+                          <a:ea typeface="Arial"/>
+                          <a:cs typeface="Arial"/>
+                        </a:rPr>
+                        <a:t>品質與查核</a:t>
+                      </a:r>
+                    </a:p>
+                  </a:txBody>
+                  <a:tcPr marL="38100" marR="38100" marT="9525" marB="9525" anchor="ctr">
+                    <a:solidFill>
+                      <a:srgbClr val="F8FAFC"/>
+                    </a:solidFill>
+                  </a:tcPr>
+                </a:tc>
+                <a:tc>
+                  <a:txBody>
+                    <a:bodyPr/>
+                    <a:lstStyle/>
+                    <a:p>
+                      <a:pPr algn="ctr"/>
+                      <a:r>
+                        <a:rPr sz="900" b="1">
+                          <a:solidFill>
+                            <a:srgbClr val="155DCC"/>
+                          </a:solidFill>
+                          <a:latin typeface="Arial"/>
+                          <a:ea typeface="Arial"/>
+                          <a:cs typeface="Arial"/>
+                        </a:rPr>
+                        <a:t>N/A</a:t>
+                      </a:r>
+                    </a:p>
+                  </a:txBody>
+                  <a:tcPr marL="38100" marR="38100" marT="9525" marB="9525" anchor="ctr">
+                    <a:solidFill>
+                      <a:srgbClr val="F8FAFC"/>
+                    </a:solidFill>
+                  </a:tcPr>
+                </a:tc>
+                <a:tc>
+                  <a:txBody>
+                    <a:bodyPr/>
+                    <a:lstStyle/>
+                    <a:p>
+                      <a:pPr algn="ctr"/>
+                      <a:r>
+                        <a:rPr sz="900" b="1">
+                          <a:solidFill>
+                            <a:srgbClr val="155DCC"/>
+                          </a:solidFill>
+                          <a:latin typeface="Arial"/>
+                          <a:ea typeface="Arial"/>
+                          <a:cs typeface="Arial"/>
+                        </a:rPr>
+                        <a:t>N/A</a:t>
+                      </a:r>
+                    </a:p>
+                  </a:txBody>
+                  <a:tcPr marL="38100" marR="38100" marT="9525" marB="9525" anchor="ctr">
+                    <a:solidFill>
+                      <a:srgbClr val="F8FAFC"/>
+                    </a:solidFill>
+                  </a:tcPr>
+                </a:tc>
+              </a:tr>
+              <a:tr h="224790">
+                <a:tc>
+                  <a:txBody>
+                    <a:bodyPr/>
+                    <a:lstStyle/>
+                    <a:p>
+                      <a:pPr algn="l"/>
+                      <a:r>
+                        <a:rPr sz="825">
+                          <a:solidFill>
+                            <a:srgbClr val="667085"/>
+                          </a:solidFill>
+                          <a:latin typeface="Arial"/>
+                          <a:ea typeface="Arial"/>
+                          <a:cs typeface="Arial"/>
+                        </a:rPr>
+                        <a:t>可複用成果</a:t>
+                      </a:r>
+                    </a:p>
+                  </a:txBody>
+                  <a:tcPr marL="38100" marR="38100" marT="9525" marB="9525" anchor="ctr">
+                    <a:solidFill>
+                      <a:srgbClr val="F8FAFC"/>
+                    </a:solidFill>
+                  </a:tcPr>
+                </a:tc>
+                <a:tc>
+                  <a:txBody>
+                    <a:bodyPr/>
+                    <a:lstStyle/>
+                    <a:p>
+                      <a:pPr algn="ctr"/>
+                      <a:r>
+                        <a:rPr sz="900" b="1">
+                          <a:solidFill>
+                            <a:srgbClr val="155DCC"/>
+                          </a:solidFill>
+                          <a:latin typeface="Arial"/>
+                          <a:ea typeface="Arial"/>
+                          <a:cs typeface="Arial"/>
+                        </a:rPr>
+                        <a:t>N/A</a:t>
+                      </a:r>
+                    </a:p>
+                  </a:txBody>
+                  <a:tcPr marL="38100" marR="38100" marT="9525" marB="9525" anchor="ctr">
+                    <a:solidFill>
+                      <a:srgbClr val="F8FAFC"/>
+                    </a:solidFill>
+                  </a:tcPr>
+                </a:tc>
+                <a:tc>
+                  <a:txBody>
+                    <a:bodyPr/>
+                    <a:lstStyle/>
+                    <a:p>
+                      <a:pPr algn="ctr"/>
+                      <a:r>
+                        <a:rPr sz="900" b="1">
+                          <a:solidFill>
+                            <a:srgbClr val="155DCC"/>
+                          </a:solidFill>
+                          <a:latin typeface="Arial"/>
+                          <a:ea typeface="Arial"/>
+                          <a:cs typeface="Arial"/>
+                        </a:rPr>
+                        <a:t>N/A</a:t>
+                      </a:r>
+                    </a:p>
+                  </a:txBody>
+                  <a:tcPr marL="38100" marR="38100" marT="9525" marB="9525" anchor="ctr">
+                    <a:solidFill>
+                      <a:srgbClr val="F8FAFC"/>
+                    </a:solidFill>
+                  </a:tcPr>
+                </a:tc>
+              </a:tr>
+              <a:tr h="224790">
+                <a:tc>
+                  <a:txBody>
+                    <a:bodyPr/>
+                    <a:lstStyle/>
+                    <a:p>
+                      <a:pPr algn="l"/>
+                      <a:r>
+                        <a:rPr sz="825">
+                          <a:solidFill>
+                            <a:srgbClr val="667085"/>
+                          </a:solidFill>
+                          <a:latin typeface="Arial"/>
+                          <a:ea typeface="Arial"/>
+                          <a:cs typeface="Arial"/>
+                        </a:rPr>
+                        <a:t>風險辨識</a:t>
+                      </a:r>
+                    </a:p>
+                  </a:txBody>
+                  <a:tcPr marL="38100" marR="38100" marT="9525" marB="9525" anchor="ctr">
+                    <a:solidFill>
+                      <a:srgbClr val="F8FAFC"/>
+                    </a:solidFill>
+                  </a:tcPr>
+                </a:tc>
+                <a:tc>
+                  <a:txBody>
+                    <a:bodyPr/>
+                    <a:lstStyle/>
+                    <a:p>
+                      <a:pPr algn="ctr"/>
+                      <a:r>
+                        <a:rPr sz="900" b="1">
+                          <a:solidFill>
+                            <a:srgbClr val="155DCC"/>
+                          </a:solidFill>
+                          <a:latin typeface="Arial"/>
+                          <a:ea typeface="Arial"/>
+                          <a:cs typeface="Arial"/>
+                        </a:rPr>
+                        <a:t>N/A</a:t>
+                      </a:r>
+                    </a:p>
+                  </a:txBody>
+                  <a:tcPr marL="38100" marR="38100" marT="9525" marB="9525" anchor="ctr">
+                    <a:solidFill>
+                      <a:srgbClr val="F8FAFC"/>
+                    </a:solidFill>
+                  </a:tcPr>
+                </a:tc>
+                <a:tc>
+                  <a:txBody>
+                    <a:bodyPr/>
+                    <a:lstStyle/>
+                    <a:p>
+                      <a:pPr algn="ctr"/>
+                      <a:r>
+                        <a:rPr sz="900" b="1">
+                          <a:solidFill>
+                            <a:srgbClr val="155DCC"/>
+                          </a:solidFill>
+                          <a:latin typeface="Arial"/>
+                          <a:ea typeface="Arial"/>
+                          <a:cs typeface="Arial"/>
+                        </a:rPr>
+                        <a:t>N/A</a:t>
+                      </a:r>
+                    </a:p>
+                  </a:txBody>
+                  <a:tcPr marL="38100" marR="38100" marT="9525" marB="9525" anchor="ctr">
+                    <a:solidFill>
+                      <a:srgbClr val="F8FAFC"/>
+                    </a:solidFill>
+                  </a:tcPr>
+                </a:tc>
+              </a:tr>
+              <a:tr h="224790">
+                <a:tc>
+                  <a:txBody>
+                    <a:bodyPr/>
+                    <a:lstStyle/>
+                    <a:p>
+                      <a:pPr algn="l"/>
+                      <a:r>
+                        <a:rPr sz="825">
+                          <a:solidFill>
+                            <a:srgbClr val="667085"/>
+                          </a:solidFill>
+                          <a:latin typeface="Arial"/>
+                          <a:ea typeface="Arial"/>
+                          <a:cs typeface="Arial"/>
+                        </a:rPr>
+                        <a:t>工作效率提升</a:t>
+                      </a:r>
+                    </a:p>
+                  </a:txBody>
+                  <a:tcPr marL="38100" marR="38100" marT="9525" marB="9525" anchor="ctr">
+                    <a:solidFill>
+                      <a:srgbClr val="F8FAFC"/>
+                    </a:solidFill>
+                  </a:tcPr>
+                </a:tc>
+                <a:tc>
+                  <a:txBody>
+                    <a:bodyPr/>
+                    <a:lstStyle/>
+                    <a:p>
+                      <a:pPr algn="ctr"/>
+                      <a:r>
+                        <a:rPr sz="900" b="1">
+                          <a:solidFill>
+                            <a:srgbClr val="155DCC"/>
+                          </a:solidFill>
+                          <a:latin typeface="Arial"/>
+                          <a:ea typeface="Arial"/>
+                          <a:cs typeface="Arial"/>
+                        </a:rPr>
+                        <a:t>N/A</a:t>
+                      </a:r>
+                    </a:p>
+                  </a:txBody>
+                  <a:tcPr marL="38100" marR="38100" marT="9525" marB="9525" anchor="ctr">
+                    <a:solidFill>
+                      <a:srgbClr val="F8FAFC"/>
+                    </a:solidFill>
+                  </a:tcPr>
+                </a:tc>
+                <a:tc>
+                  <a:txBody>
+                    <a:bodyPr/>
+                    <a:lstStyle/>
+                    <a:p>
+                      <a:pPr algn="ctr"/>
+                      <a:r>
+                        <a:rPr sz="900" b="1">
+                          <a:solidFill>
+                            <a:srgbClr val="155DCC"/>
+                          </a:solidFill>
+                          <a:latin typeface="Arial"/>
+                          <a:ea typeface="Arial"/>
+                          <a:cs typeface="Arial"/>
+                        </a:rPr>
+                        <a:t>N/A</a:t>
+                      </a:r>
+                    </a:p>
+                  </a:txBody>
+                  <a:tcPr marL="38100" marR="38100" marT="9525" marB="9525" anchor="ctr">
+                    <a:solidFill>
+                      <a:srgbClr val="F8FAFC"/>
+                    </a:solidFill>
+                  </a:tcPr>
+                </a:tc>
+              </a:tr>
+            </a:tbl>
+          </a:graphicData>
+        </a:graphic>
+      </p:graphicFrame>
     </p:spTree>
     <p:extLst>
       <p:ext uri="{BB962C8B-B14F-4D97-AF65-F5344CB8AC3E}">

</xml_diff>